<commit_message>
Update onboarding deck: LLC name, BYO supplies, pay schedule, BK app note
Co-Authored-By: Claude Opus 4.8 <noreply@anthropic.com>
</commit_message>
<xml_diff>
--- a/docs/North_Columbus_Cleaner_Onboarding.pptx
+++ b/docs/North_Columbus_Cleaner_Onboarding.pptx
@@ -1889,7 +1889,7 @@
                 <a:ea typeface="Inter" pitchFamily="34" charset="-122"/>
                 <a:cs typeface="Inter" pitchFamily="34" charset="-120"/>
               </a:rPr>
-              <a:t>NORTH COLUMBUS CLEANING COMPANY</a:t>
+              <a:t>NORTH COLUMBUS CLEANING LLC</a:t>
             </a:r>
             <a:endParaRPr lang="en-US" sz="1400" dirty="0"/>
           </a:p>
@@ -4575,7 +4575,7 @@
                 <a:ea typeface="Inter" pitchFamily="34" charset="-122"/>
                 <a:cs typeface="Inter" pitchFamily="34" charset="-120"/>
               </a:rPr>
-              <a:t>Supplies &amp; equipment</a:t>
+              <a:t>Your supplies &amp; equipment</a:t>
             </a:r>
             <a:endParaRPr lang="en-US" sz="4000" dirty="0"/>
           </a:p>
@@ -4617,7 +4617,7 @@
                 <a:ea typeface="Inter" pitchFamily="34" charset="-122"/>
                 <a:cs typeface="Inter" pitchFamily="34" charset="-120"/>
               </a:rPr>
-              <a:t>We trust you to choose the right products for each job. The checklist below covers the supplies and equipment we recommend to keep our clients' spaces clean to our standard.</a:t>
+              <a:t>As an independent contractor, you provide your own cleaning supplies and equipment for every job, at your own expense. The checklist below shows what's cleaned at each service level.</a:t>
             </a:r>
             <a:endParaRPr lang="en-US" sz="2000" dirty="0"/>
           </a:p>
@@ -4687,7 +4687,7 @@
                   </a:extLst>
                 </a:hlinkClick>
               </a:rPr>
-              <a:t>VIEW THE CLEANING SUPPLY CHECKLIST</a:t>
+              <a:t>VIEW THE CLEANING CHECKLIST</a:t>
             </a:r>
             <a:endParaRPr lang="en-US" sz="1400" dirty="0"/>
           </a:p>
@@ -5008,7 +5008,7 @@
                 <a:ea typeface="Inter" pitchFamily="34" charset="-122"/>
                 <a:cs typeface="Inter" pitchFamily="34" charset="-120"/>
               </a:rPr>
-              <a:t>Download the Booking Koala for Providers app from the Apple App Store or Google Play to manage your work.</a:t>
+              <a:t>Download the Booking Koala for Providers app from the App Store or Google Play — direct links are in your welcome email and the online onboarding guide.</a:t>
             </a:r>
             <a:endParaRPr lang="en-US" sz="2000" dirty="0"/>
           </a:p>
@@ -5681,7 +5681,7 @@
                 <a:ea typeface="Inter" pitchFamily="34" charset="-122"/>
                 <a:cs typeface="Inter" pitchFamily="34" charset="-120"/>
               </a:rPr>
-              <a:t>We're committed to completing every job to a high standard. We pay by the job, not by the hour, to keep the focus on thoroughness and quality.</a:t>
+              <a:t>We're committed to completing every job to a high standard. We pay by the job, not by the hour — issued on Wednesday of the week after the work is done — to keep the focus on quality.</a:t>
             </a:r>
             <a:endParaRPr lang="en-US" sz="2000" dirty="0"/>
           </a:p>

</xml_diff>